<commit_message>
Materiais secundários regenerados pelo gerador: kickoff, certificados, cartão
Os três últimos materiais da era antiga viram alvos do gerador: deck de
kickoff (12 slides, o caminho agora mostra as 3 fases com os Portões e
Termos de Aceite), os dois certificados (moldura dupla navy/ouro) e o
cartão de descoberta do protótipo (A4, 2 páginas, 7 blocos; a integração
real referida como fase 2 do Programa). Sem travessão, QA visual página
a página. Catálogo atualizado.

Co-Authored-By: Claude Fable 5 <noreply@anthropic.com>
Claude-Session: https://claude.ai/code/session_016RZJT8nVEB7u33HvjY5KvZ
</commit_message>
<xml_diff>
--- a/08-materiais/modelos/certificados-modelo.pptx
+++ b/08-materiais/modelos/certificados-modelo.pptx
@@ -11,8 +11,8 @@
   <p:notesMasterIdLst>
     <p:notesMasterId r:id="rId4"/>
   </p:notesMasterIdLst>
-  <p:sldSz cx="12192000" cy="6858000"/>
-  <p:notesSz cx="6858000" cy="12192000"/>
+  <p:sldSz cx="12188952" cy="6858000"/>
+  <p:notesSz cx="6858000" cy="12188952"/>
   <p:defaultTextStyle>
     <a:lvl1pPr marL="0" algn="l" defTabSz="914400" rtl="0" eaLnBrk="1" latinLnBrk="0" hangingPunct="1">
       <a:defRPr sz="1800" kern="1200">
@@ -946,7 +946,7 @@
     <p:bg>
       <p:bgPr>
         <a:solidFill>
-          <a:srgbClr val="1B2A4A"/>
+          <a:srgbClr val="FFFFFF"/>
         </a:solidFill>
       </p:bgPr>
     </p:bg>
@@ -973,12 +973,12 @@
         <p:spPr>
           <a:xfrm>
             <a:off x="320040" y="320040"/>
-            <a:ext cx="11521440" cy="6217920"/>
-          </a:xfrm>
-          <a:prstGeom prst="rect">
-            <a:avLst/>
-          </a:prstGeom>
-          <a:ln w="25400">
+            <a:ext cx="11548872" cy="6217920"/>
+          </a:xfrm>
+          <a:prstGeom prst="rect">
+            <a:avLst/>
+          </a:prstGeom>
+          <a:ln w="19050">
             <a:solidFill>
               <a:srgbClr val="C2A35B"/>
             </a:solidFill>
@@ -995,53 +995,29 @@
         <p:spPr>
           <a:xfrm>
             <a:off x="457200" y="457200"/>
-            <a:ext cx="11247120" cy="5943600"/>
+            <a:ext cx="11274552" cy="5943600"/>
           </a:xfrm>
           <a:prstGeom prst="rect">
             <a:avLst/>
           </a:prstGeom>
           <a:ln w="9525">
             <a:solidFill>
-              <a:srgbClr val="C2A35B"/>
+              <a:srgbClr val="E5E0D4"/>
             </a:solidFill>
             <a:prstDash val="solid"/>
           </a:ln>
         </p:spPr>
       </p:sp>
-      <p:pic>
-        <p:nvPicPr>
-          <p:cNvPr id="4" name="Image 0" descr="preencoded.png">    </p:cNvPr>
-          <p:cNvPicPr>
-            <a:picLocks noChangeAspect="1"/>
-          </p:cNvPicPr>
-          <p:nvPr/>
-        </p:nvPicPr>
-        <p:blipFill>
-          <a:blip r:embed="rId1"/>
-          <a:stretch>
-            <a:fillRect/>
-          </a:stretch>
-        </p:blipFill>
-        <p:spPr>
-          <a:xfrm>
-            <a:off x="5532120" y="777240"/>
-            <a:ext cx="1097280" cy="1207008"/>
-          </a:xfrm>
-          <a:prstGeom prst="rect">
-            <a:avLst/>
-          </a:prstGeom>
-        </p:spPr>
-      </p:pic>
-      <p:sp>
-        <p:nvSpPr>
-          <p:cNvPr id="5" name="Text 2"/>
-          <p:cNvSpPr/>
-          <p:nvPr/>
-        </p:nvSpPr>
-        <p:spPr>
-          <a:xfrm>
-            <a:off x="548640" y="2103120"/>
-            <a:ext cx="11064240" cy="365760"/>
+      <p:sp>
+        <p:nvSpPr>
+          <p:cNvPr id="4" name="Text 2"/>
+          <p:cNvSpPr/>
+          <p:nvPr/>
+        </p:nvSpPr>
+        <p:spPr>
+          <a:xfrm>
+            <a:off x="822960" y="868680"/>
+            <a:ext cx="10543032" cy="320040"/>
           </a:xfrm>
           <a:prstGeom prst="rect">
             <a:avLst/>
@@ -1050,14 +1026,14 @@
           <a:ln/>
         </p:spPr>
         <p:txBody>
-          <a:bodyPr wrap="square" lIns="0" tIns="0" rIns="0" bIns="0" rtlCol="0" anchor="ctr"/>
+          <a:bodyPr wrap="square" rtlCol="0" anchor="ctr"/>
           <a:lstStyle/>
           <a:p>
             <a:pPr algn="ctr" indent="0" marL="0">
               <a:buNone/>
             </a:pPr>
             <a:r>
-              <a:rPr lang="en-US" sz="1400" spc="300" kern="0" dirty="0">
+              <a:rPr lang="en-US" sz="1200" b="1" spc="400" kern="0" dirty="0">
                 <a:solidFill>
                   <a:srgbClr val="C2A35B"/>
                 </a:solidFill>
@@ -1067,20 +1043,20 @@
               </a:rPr>
               <a:t>ABBA · Consultoria de IA</a:t>
             </a:r>
-            <a:endParaRPr lang="en-US" sz="1400" dirty="0"/>
-          </a:p>
-        </p:txBody>
-      </p:sp>
-      <p:sp>
-        <p:nvSpPr>
-          <p:cNvPr id="6" name="Text 3"/>
-          <p:cNvSpPr/>
-          <p:nvPr/>
-        </p:nvSpPr>
-        <p:spPr>
-          <a:xfrm>
-            <a:off x="548640" y="2514600"/>
-            <a:ext cx="11064240" cy="685800"/>
+            <a:endParaRPr lang="en-US" sz="1200" dirty="0"/>
+          </a:p>
+        </p:txBody>
+      </p:sp>
+      <p:sp>
+        <p:nvSpPr>
+          <p:cNvPr id="5" name="Text 3"/>
+          <p:cNvSpPr/>
+          <p:nvPr/>
+        </p:nvSpPr>
+        <p:spPr>
+          <a:xfrm>
+            <a:off x="822960" y="1417320"/>
+            <a:ext cx="10543032" cy="822960"/>
           </a:xfrm>
           <a:prstGeom prst="rect">
             <a:avLst/>
@@ -1089,37 +1065,141 @@
           <a:ln/>
         </p:spPr>
         <p:txBody>
-          <a:bodyPr wrap="square" lIns="0" tIns="0" rIns="0" bIns="0" rtlCol="0" anchor="ctr"/>
+          <a:bodyPr wrap="square" rtlCol="0" anchor="ctr"/>
           <a:lstStyle/>
           <a:p>
             <a:pPr algn="ctr" indent="0" marL="0">
               <a:buNone/>
             </a:pPr>
             <a:r>
-              <a:rPr lang="en-US" sz="3400" b="1" dirty="0">
+              <a:rPr lang="en-US" sz="3600" b="1" dirty="0">
                 <a:solidFill>
-                  <a:srgbClr val="FFFFFF"/>
+                  <a:srgbClr val="1B2A4A"/>
+                </a:solidFill>
+                <a:latin typeface="Cambria" pitchFamily="34" charset="0"/>
+                <a:ea typeface="Cambria" pitchFamily="34" charset="-122"/>
+                <a:cs typeface="Cambria" pitchFamily="34" charset="-120"/>
+              </a:rPr>
+              <a:t>Certificado de Conclusão</a:t>
+            </a:r>
+            <a:endParaRPr lang="en-US" sz="3600" dirty="0"/>
+          </a:p>
+        </p:txBody>
+      </p:sp>
+      <p:sp>
+        <p:nvSpPr>
+          <p:cNvPr id="6" name="Shape 4"/>
+          <p:cNvSpPr/>
+          <p:nvPr/>
+        </p:nvSpPr>
+        <p:spPr>
+          <a:xfrm>
+            <a:off x="5088636" y="2377440"/>
+            <a:ext cx="2011680" cy="0"/>
+          </a:xfrm>
+          <a:prstGeom prst="line">
+            <a:avLst/>
+          </a:prstGeom>
+          <a:noFill/>
+          <a:ln w="19050">
+            <a:solidFill>
+              <a:srgbClr val="C2A35B"/>
+            </a:solidFill>
+            <a:prstDash val="solid"/>
+          </a:ln>
+        </p:spPr>
+      </p:sp>
+      <p:sp>
+        <p:nvSpPr>
+          <p:cNvPr id="7" name="Text 5"/>
+          <p:cNvSpPr/>
+          <p:nvPr/>
+        </p:nvSpPr>
+        <p:spPr>
+          <a:xfrm>
+            <a:off x="822960" y="2697480"/>
+            <a:ext cx="10543032" cy="685800"/>
+          </a:xfrm>
+          <a:prstGeom prst="rect">
+            <a:avLst/>
+          </a:prstGeom>
+          <a:noFill/>
+          <a:ln/>
+        </p:spPr>
+        <p:txBody>
+          <a:bodyPr wrap="square" rtlCol="0" anchor="ctr"/>
+          <a:lstStyle/>
+          <a:p>
+            <a:pPr algn="ctr" indent="0" marL="0">
+              <a:buNone/>
+            </a:pPr>
+            <a:r>
+              <a:rPr lang="en-US" sz="3000" i="1" dirty="0">
+                <a:solidFill>
+                  <a:srgbClr val="33394A"/>
+                </a:solidFill>
+                <a:latin typeface="Cambria" pitchFamily="34" charset="0"/>
+                <a:ea typeface="Cambria" pitchFamily="34" charset="-122"/>
+                <a:cs typeface="Cambria" pitchFamily="34" charset="-120"/>
+              </a:rPr>
+              <a:t>{{NOME DO PARTICIPANTE}}</a:t>
+            </a:r>
+            <a:endParaRPr lang="en-US" sz="3000" dirty="0"/>
+          </a:p>
+        </p:txBody>
+      </p:sp>
+      <p:sp>
+        <p:nvSpPr>
+          <p:cNvPr id="8" name="Text 6"/>
+          <p:cNvSpPr/>
+          <p:nvPr/>
+        </p:nvSpPr>
+        <p:spPr>
+          <a:xfrm>
+            <a:off x="1920240" y="3520440"/>
+            <a:ext cx="8348472" cy="1371600"/>
+          </a:xfrm>
+          <a:prstGeom prst="rect">
+            <a:avLst/>
+          </a:prstGeom>
+          <a:noFill/>
+          <a:ln/>
+        </p:spPr>
+        <p:txBody>
+          <a:bodyPr wrap="square" rtlCol="0" anchor="ctr"/>
+          <a:lstStyle/>
+          <a:p>
+            <a:pPr algn="ctr" indent="0" marL="0">
+              <a:lnSpc>
+                <a:spcPts val="2200"/>
+              </a:lnSpc>
+              <a:buNone/>
+            </a:pPr>
+            <a:r>
+              <a:rPr lang="en-US" sz="1400" dirty="0">
+                <a:solidFill>
+                  <a:srgbClr val="33394A"/>
                 </a:solidFill>
                 <a:latin typeface="Calibri" pitchFamily="34" charset="0"/>
                 <a:ea typeface="Calibri" pitchFamily="34" charset="-122"/>
                 <a:cs typeface="Calibri" pitchFamily="34" charset="-120"/>
               </a:rPr>
-              <a:t>Certificado de Conclusão</a:t>
+              <a:t>concluiu o programa de capacitação em Inteligência Artificial da ABBA ({{fase/trilha}}, na {{NOME_DA_EMPRESA}}), demonstrando domínio prático das três perguntas: o que parar, o que começar e o que ainda é essencialmente humano.</a:t>
             </a:r>
-            <a:endParaRPr lang="en-US" sz="3400" dirty="0"/>
-          </a:p>
-        </p:txBody>
-      </p:sp>
-      <p:sp>
-        <p:nvSpPr>
-          <p:cNvPr id="7" name="Text 4"/>
-          <p:cNvSpPr/>
-          <p:nvPr/>
-        </p:nvSpPr>
-        <p:spPr>
-          <a:xfrm>
-            <a:off x="548640" y="3383280"/>
-            <a:ext cx="11064240" cy="685800"/>
+            <a:endParaRPr lang="en-US" sz="1400" dirty="0"/>
+          </a:p>
+        </p:txBody>
+      </p:sp>
+      <p:sp>
+        <p:nvSpPr>
+          <p:cNvPr id="9" name="Text 7"/>
+          <p:cNvSpPr/>
+          <p:nvPr/>
+        </p:nvSpPr>
+        <p:spPr>
+          <a:xfrm>
+            <a:off x="822960" y="4983480"/>
+            <a:ext cx="10543032" cy="320040"/>
           </a:xfrm>
           <a:prstGeom prst="rect">
             <a:avLst/>
@@ -1128,37 +1208,60 @@
           <a:ln/>
         </p:spPr>
         <p:txBody>
-          <a:bodyPr wrap="square" lIns="0" tIns="0" rIns="0" bIns="0" rtlCol="0" anchor="ctr"/>
+          <a:bodyPr wrap="square" rtlCol="0" anchor="ctr"/>
           <a:lstStyle/>
           <a:p>
             <a:pPr algn="ctr" indent="0" marL="0">
               <a:buNone/>
             </a:pPr>
             <a:r>
-              <a:rPr lang="en-US" sz="3200" b="1" dirty="0">
+              <a:rPr lang="en-US" sz="1100" dirty="0">
                 <a:solidFill>
-                  <a:srgbClr val="C2A35B"/>
+                  <a:srgbClr val="6E6858"/>
                 </a:solidFill>
                 <a:latin typeface="Calibri" pitchFamily="34" charset="0"/>
                 <a:ea typeface="Calibri" pitchFamily="34" charset="-122"/>
                 <a:cs typeface="Calibri" pitchFamily="34" charset="-120"/>
               </a:rPr>
-              <a:t>{{NOME DO PARTICIPANTE}}</a:t>
+              <a:t>{{Cidade}}, {{data}}   ·   Verificação: ABBA-CERT-{{ANO}}-{{NUM}}</a:t>
             </a:r>
-            <a:endParaRPr lang="en-US" sz="3200" dirty="0"/>
-          </a:p>
-        </p:txBody>
-      </p:sp>
-      <p:sp>
-        <p:nvSpPr>
-          <p:cNvPr id="8" name="Text 5"/>
-          <p:cNvSpPr/>
-          <p:nvPr/>
-        </p:nvSpPr>
-        <p:spPr>
-          <a:xfrm>
-            <a:off x="1463040" y="4160520"/>
-            <a:ext cx="9235440" cy="868680"/>
+            <a:endParaRPr lang="en-US" sz="1100" dirty="0"/>
+          </a:p>
+        </p:txBody>
+      </p:sp>
+      <p:sp>
+        <p:nvSpPr>
+          <p:cNvPr id="10" name="Shape 8"/>
+          <p:cNvSpPr/>
+          <p:nvPr/>
+        </p:nvSpPr>
+        <p:spPr>
+          <a:xfrm>
+            <a:off x="2528316" y="5806440"/>
+            <a:ext cx="3108960" cy="0"/>
+          </a:xfrm>
+          <a:prstGeom prst="line">
+            <a:avLst/>
+          </a:prstGeom>
+          <a:noFill/>
+          <a:ln w="9525">
+            <a:solidFill>
+              <a:srgbClr val="6E6858"/>
+            </a:solidFill>
+            <a:prstDash val="solid"/>
+          </a:ln>
+        </p:spPr>
+      </p:sp>
+      <p:sp>
+        <p:nvSpPr>
+          <p:cNvPr id="11" name="Text 9"/>
+          <p:cNvSpPr/>
+          <p:nvPr/>
+        </p:nvSpPr>
+        <p:spPr>
+          <a:xfrm>
+            <a:off x="2528316" y="5897880"/>
+            <a:ext cx="3108960" cy="274320"/>
           </a:xfrm>
           <a:prstGeom prst="rect">
             <a:avLst/>
@@ -1167,140 +1270,16 @@
           <a:ln/>
         </p:spPr>
         <p:txBody>
-          <a:bodyPr wrap="square" lIns="0" tIns="0" rIns="0" bIns="0" rtlCol="0" anchor="ctr"/>
+          <a:bodyPr wrap="square" rtlCol="0" anchor="ctr"/>
           <a:lstStyle/>
           <a:p>
             <a:pPr algn="ctr" indent="0" marL="0">
               <a:buNone/>
             </a:pPr>
             <a:r>
-              <a:rPr lang="en-US" sz="1400" dirty="0">
+              <a:rPr lang="en-US" sz="1100" dirty="0">
                 <a:solidFill>
-                  <a:srgbClr val="E8E8E8"/>
-                </a:solidFill>
-                <a:latin typeface="Calibri" pitchFamily="34" charset="0"/>
-                <a:ea typeface="Calibri" pitchFamily="34" charset="-122"/>
-                <a:cs typeface="Calibri" pitchFamily="34" charset="-120"/>
-              </a:rPr>
-              <a:t>concluiu o programa de capacitação em Inteligência Artificial da ABBA — {{fase/trilha}}, na {{NOME_DA_EMPRESA}} — demonstrando domínio prático das três perguntas: o que parar, o que começar e o que ainda é essencialmente humano.</a:t>
-            </a:r>
-            <a:endParaRPr lang="en-US" sz="1400" dirty="0"/>
-          </a:p>
-        </p:txBody>
-      </p:sp>
-      <p:sp>
-        <p:nvSpPr>
-          <p:cNvPr id="9" name="Text 6"/>
-          <p:cNvSpPr/>
-          <p:nvPr/>
-        </p:nvSpPr>
-        <p:spPr>
-          <a:xfrm>
-            <a:off x="1463040" y="5074920"/>
-            <a:ext cx="9235440" cy="365760"/>
-          </a:xfrm>
-          <a:prstGeom prst="rect">
-            <a:avLst/>
-          </a:prstGeom>
-          <a:noFill/>
-          <a:ln/>
-        </p:spPr>
-        <p:txBody>
-          <a:bodyPr wrap="square" lIns="0" tIns="0" rIns="0" bIns="0" rtlCol="0" anchor="ctr"/>
-          <a:lstStyle/>
-          <a:p>
-            <a:pPr algn="ctr" indent="0" marL="0">
-              <a:buNone/>
-            </a:pPr>
-            <a:r>
-              <a:rPr lang="en-US" sz="1200" i="1" dirty="0">
-                <a:solidFill>
-                  <a:srgbClr val="5A6472"/>
-                </a:solidFill>
-                <a:latin typeface="Calibri" pitchFamily="34" charset="0"/>
-                <a:ea typeface="Calibri" pitchFamily="34" charset="-122"/>
-                <a:cs typeface="Calibri" pitchFamily="34" charset="-120"/>
-              </a:rPr>
-              <a:t>{{Cidade}}, {{data}} · Verificação: ABBA-CERT-{{ANO}}-{{NUM}}</a:t>
-            </a:r>
-            <a:endParaRPr lang="en-US" sz="1200" dirty="0"/>
-          </a:p>
-        </p:txBody>
-      </p:sp>
-      <p:sp>
-        <p:nvSpPr>
-          <p:cNvPr id="10" name="Shape 7"/>
-          <p:cNvSpPr/>
-          <p:nvPr/>
-        </p:nvSpPr>
-        <p:spPr>
-          <a:xfrm>
-            <a:off x="3108960" y="5806440"/>
-            <a:ext cx="2377440" cy="0"/>
-          </a:xfrm>
-          <a:prstGeom prst="line">
-            <a:avLst/>
-          </a:prstGeom>
-          <a:noFill/>
-          <a:ln w="12700">
-            <a:solidFill>
-              <a:srgbClr val="E8E8E8"/>
-            </a:solidFill>
-            <a:prstDash val="solid"/>
-          </a:ln>
-        </p:spPr>
-      </p:sp>
-      <p:sp>
-        <p:nvSpPr>
-          <p:cNvPr id="11" name="Shape 8"/>
-          <p:cNvSpPr/>
-          <p:nvPr/>
-        </p:nvSpPr>
-        <p:spPr>
-          <a:xfrm>
-            <a:off x="6675120" y="5806440"/>
-            <a:ext cx="2377440" cy="0"/>
-          </a:xfrm>
-          <a:prstGeom prst="line">
-            <a:avLst/>
-          </a:prstGeom>
-          <a:noFill/>
-          <a:ln w="12700">
-            <a:solidFill>
-              <a:srgbClr val="E8E8E8"/>
-            </a:solidFill>
-            <a:prstDash val="solid"/>
-          </a:ln>
-        </p:spPr>
-      </p:sp>
-      <p:sp>
-        <p:nvSpPr>
-          <p:cNvPr id="12" name="Text 9"/>
-          <p:cNvSpPr/>
-          <p:nvPr/>
-        </p:nvSpPr>
-        <p:spPr>
-          <a:xfrm>
-            <a:off x="3108960" y="5870448"/>
-            <a:ext cx="2377440" cy="274320"/>
-          </a:xfrm>
-          <a:prstGeom prst="rect">
-            <a:avLst/>
-          </a:prstGeom>
-          <a:noFill/>
-          <a:ln/>
-        </p:spPr>
-        <p:txBody>
-          <a:bodyPr wrap="square" lIns="0" tIns="0" rIns="0" bIns="0" rtlCol="0" anchor="ctr"/>
-          <a:lstStyle/>
-          <a:p>
-            <a:pPr algn="ctr" indent="0" marL="0">
-              <a:buNone/>
-            </a:pPr>
-            <a:r>
-              <a:rPr lang="en-US" sz="1000" dirty="0">
-                <a:solidFill>
-                  <a:srgbClr val="5A6472"/>
+                  <a:srgbClr val="33394A"/>
                 </a:solidFill>
                 <a:latin typeface="Calibri" pitchFamily="34" charset="0"/>
                 <a:ea typeface="Calibri" pitchFamily="34" charset="-122"/>
@@ -1308,20 +1287,43 @@
               </a:rPr>
               <a:t>{{Sócio A}} · ABBA</a:t>
             </a:r>
-            <a:endParaRPr lang="en-US" sz="1000" dirty="0"/>
-          </a:p>
-        </p:txBody>
-      </p:sp>
-      <p:sp>
-        <p:nvSpPr>
-          <p:cNvPr id="13" name="Text 10"/>
-          <p:cNvSpPr/>
-          <p:nvPr/>
-        </p:nvSpPr>
-        <p:spPr>
-          <a:xfrm>
-            <a:off x="6675120" y="5870448"/>
-            <a:ext cx="2377440" cy="274320"/>
+            <a:endParaRPr lang="en-US" sz="1100" dirty="0"/>
+          </a:p>
+        </p:txBody>
+      </p:sp>
+      <p:sp>
+        <p:nvSpPr>
+          <p:cNvPr id="12" name="Shape 10"/>
+          <p:cNvSpPr/>
+          <p:nvPr/>
+        </p:nvSpPr>
+        <p:spPr>
+          <a:xfrm>
+            <a:off x="6551676" y="5806440"/>
+            <a:ext cx="3108960" cy="0"/>
+          </a:xfrm>
+          <a:prstGeom prst="line">
+            <a:avLst/>
+          </a:prstGeom>
+          <a:noFill/>
+          <a:ln w="9525">
+            <a:solidFill>
+              <a:srgbClr val="6E6858"/>
+            </a:solidFill>
+            <a:prstDash val="solid"/>
+          </a:ln>
+        </p:spPr>
+      </p:sp>
+      <p:sp>
+        <p:nvSpPr>
+          <p:cNvPr id="13" name="Text 11"/>
+          <p:cNvSpPr/>
+          <p:nvPr/>
+        </p:nvSpPr>
+        <p:spPr>
+          <a:xfrm>
+            <a:off x="6551676" y="5897880"/>
+            <a:ext cx="3108960" cy="274320"/>
           </a:xfrm>
           <a:prstGeom prst="rect">
             <a:avLst/>
@@ -1330,16 +1332,16 @@
           <a:ln/>
         </p:spPr>
         <p:txBody>
-          <a:bodyPr wrap="square" lIns="0" tIns="0" rIns="0" bIns="0" rtlCol="0" anchor="ctr"/>
+          <a:bodyPr wrap="square" rtlCol="0" anchor="ctr"/>
           <a:lstStyle/>
           <a:p>
             <a:pPr algn="ctr" indent="0" marL="0">
               <a:buNone/>
             </a:pPr>
             <a:r>
-              <a:rPr lang="en-US" sz="1000" dirty="0">
+              <a:rPr lang="en-US" sz="1100" dirty="0">
                 <a:solidFill>
-                  <a:srgbClr val="5A6472"/>
+                  <a:srgbClr val="33394A"/>
                 </a:solidFill>
                 <a:latin typeface="Calibri" pitchFamily="34" charset="0"/>
                 <a:ea typeface="Calibri" pitchFamily="34" charset="-122"/>
@@ -1347,7 +1349,7 @@
               </a:rPr>
               <a:t>{{Sócio B}} · ABBA</a:t>
             </a:r>
-            <a:endParaRPr lang="en-US" sz="1000" dirty="0"/>
+            <a:endParaRPr lang="en-US" sz="1100" dirty="0"/>
           </a:p>
         </p:txBody>
       </p:sp>
@@ -1365,7 +1367,7 @@
     <p:bg>
       <p:bgPr>
         <a:solidFill>
-          <a:srgbClr val="1B2A4A"/>
+          <a:srgbClr val="FFFFFF"/>
         </a:solidFill>
       </p:bgPr>
     </p:bg>
@@ -1392,12 +1394,12 @@
         <p:spPr>
           <a:xfrm>
             <a:off x="320040" y="320040"/>
-            <a:ext cx="11521440" cy="6217920"/>
-          </a:xfrm>
-          <a:prstGeom prst="rect">
-            <a:avLst/>
-          </a:prstGeom>
-          <a:ln w="25400">
+            <a:ext cx="11548872" cy="6217920"/>
+          </a:xfrm>
+          <a:prstGeom prst="rect">
+            <a:avLst/>
+          </a:prstGeom>
+          <a:ln w="19050">
             <a:solidFill>
               <a:srgbClr val="C2A35B"/>
             </a:solidFill>
@@ -1414,53 +1416,29 @@
         <p:spPr>
           <a:xfrm>
             <a:off x="457200" y="457200"/>
-            <a:ext cx="11247120" cy="5943600"/>
+            <a:ext cx="11274552" cy="5943600"/>
           </a:xfrm>
           <a:prstGeom prst="rect">
             <a:avLst/>
           </a:prstGeom>
           <a:ln w="9525">
             <a:solidFill>
-              <a:srgbClr val="C2A35B"/>
+              <a:srgbClr val="E5E0D4"/>
             </a:solidFill>
             <a:prstDash val="solid"/>
           </a:ln>
         </p:spPr>
       </p:sp>
-      <p:pic>
-        <p:nvPicPr>
-          <p:cNvPr id="4" name="Image 0" descr="preencoded.png">    </p:cNvPr>
-          <p:cNvPicPr>
-            <a:picLocks noChangeAspect="1"/>
-          </p:cNvPicPr>
-          <p:nvPr/>
-        </p:nvPicPr>
-        <p:blipFill>
-          <a:blip r:embed="rId1"/>
-          <a:stretch>
-            <a:fillRect/>
-          </a:stretch>
-        </p:blipFill>
-        <p:spPr>
-          <a:xfrm>
-            <a:off x="5532120" y="777240"/>
-            <a:ext cx="1097280" cy="1207008"/>
-          </a:xfrm>
-          <a:prstGeom prst="rect">
-            <a:avLst/>
-          </a:prstGeom>
-        </p:spPr>
-      </p:pic>
-      <p:sp>
-        <p:nvSpPr>
-          <p:cNvPr id="5" name="Text 2"/>
-          <p:cNvSpPr/>
-          <p:nvPr/>
-        </p:nvSpPr>
-        <p:spPr>
-          <a:xfrm>
-            <a:off x="548640" y="2103120"/>
-            <a:ext cx="11064240" cy="365760"/>
+      <p:sp>
+        <p:nvSpPr>
+          <p:cNvPr id="4" name="Text 2"/>
+          <p:cNvSpPr/>
+          <p:nvPr/>
+        </p:nvSpPr>
+        <p:spPr>
+          <a:xfrm>
+            <a:off x="822960" y="868680"/>
+            <a:ext cx="10543032" cy="320040"/>
           </a:xfrm>
           <a:prstGeom prst="rect">
             <a:avLst/>
@@ -1469,14 +1447,14 @@
           <a:ln/>
         </p:spPr>
         <p:txBody>
-          <a:bodyPr wrap="square" lIns="0" tIns="0" rIns="0" bIns="0" rtlCol="0" anchor="ctr"/>
+          <a:bodyPr wrap="square" rtlCol="0" anchor="ctr"/>
           <a:lstStyle/>
           <a:p>
             <a:pPr algn="ctr" indent="0" marL="0">
               <a:buNone/>
             </a:pPr>
             <a:r>
-              <a:rPr lang="en-US" sz="1400" spc="300" kern="0" dirty="0">
+              <a:rPr lang="en-US" sz="1200" b="1" spc="400" kern="0" dirty="0">
                 <a:solidFill>
                   <a:srgbClr val="C2A35B"/>
                 </a:solidFill>
@@ -1486,20 +1464,20 @@
               </a:rPr>
               <a:t>ABBA · Consultoria de IA</a:t>
             </a:r>
-            <a:endParaRPr lang="en-US" sz="1400" dirty="0"/>
-          </a:p>
-        </p:txBody>
-      </p:sp>
-      <p:sp>
-        <p:nvSpPr>
-          <p:cNvPr id="6" name="Text 3"/>
-          <p:cNvSpPr/>
-          <p:nvPr/>
-        </p:nvSpPr>
-        <p:spPr>
-          <a:xfrm>
-            <a:off x="548640" y="2514600"/>
-            <a:ext cx="11064240" cy="685800"/>
+            <a:endParaRPr lang="en-US" sz="1200" dirty="0"/>
+          </a:p>
+        </p:txBody>
+      </p:sp>
+      <p:sp>
+        <p:nvSpPr>
+          <p:cNvPr id="5" name="Text 3"/>
+          <p:cNvSpPr/>
+          <p:nvPr/>
+        </p:nvSpPr>
+        <p:spPr>
+          <a:xfrm>
+            <a:off x="822960" y="1417320"/>
+            <a:ext cx="10543032" cy="822960"/>
           </a:xfrm>
           <a:prstGeom prst="rect">
             <a:avLst/>
@@ -1508,37 +1486,141 @@
           <a:ln/>
         </p:spPr>
         <p:txBody>
-          <a:bodyPr wrap="square" lIns="0" tIns="0" rIns="0" bIns="0" rtlCol="0" anchor="ctr"/>
+          <a:bodyPr wrap="square" rtlCol="0" anchor="ctr"/>
           <a:lstStyle/>
           <a:p>
             <a:pPr algn="ctr" indent="0" marL="0">
               <a:buNone/>
             </a:pPr>
             <a:r>
-              <a:rPr lang="en-US" sz="3400" b="1" dirty="0">
+              <a:rPr lang="en-US" sz="3600" b="1" dirty="0">
                 <a:solidFill>
-                  <a:srgbClr val="FFFFFF"/>
+                  <a:srgbClr val="1B2A4A"/>
+                </a:solidFill>
+                <a:latin typeface="Cambria" pitchFamily="34" charset="0"/>
+                <a:ea typeface="Cambria" pitchFamily="34" charset="-122"/>
+                <a:cs typeface="Cambria" pitchFamily="34" charset="-120"/>
+              </a:rPr>
+              <a:t>Certificação de Campeão ABBA</a:t>
+            </a:r>
+            <a:endParaRPr lang="en-US" sz="3600" dirty="0"/>
+          </a:p>
+        </p:txBody>
+      </p:sp>
+      <p:sp>
+        <p:nvSpPr>
+          <p:cNvPr id="6" name="Shape 4"/>
+          <p:cNvSpPr/>
+          <p:nvPr/>
+        </p:nvSpPr>
+        <p:spPr>
+          <a:xfrm>
+            <a:off x="5088636" y="2377440"/>
+            <a:ext cx="2011680" cy="0"/>
+          </a:xfrm>
+          <a:prstGeom prst="line">
+            <a:avLst/>
+          </a:prstGeom>
+          <a:noFill/>
+          <a:ln w="19050">
+            <a:solidFill>
+              <a:srgbClr val="C2A35B"/>
+            </a:solidFill>
+            <a:prstDash val="solid"/>
+          </a:ln>
+        </p:spPr>
+      </p:sp>
+      <p:sp>
+        <p:nvSpPr>
+          <p:cNvPr id="7" name="Text 5"/>
+          <p:cNvSpPr/>
+          <p:nvPr/>
+        </p:nvSpPr>
+        <p:spPr>
+          <a:xfrm>
+            <a:off x="822960" y="2697480"/>
+            <a:ext cx="10543032" cy="685800"/>
+          </a:xfrm>
+          <a:prstGeom prst="rect">
+            <a:avLst/>
+          </a:prstGeom>
+          <a:noFill/>
+          <a:ln/>
+        </p:spPr>
+        <p:txBody>
+          <a:bodyPr wrap="square" rtlCol="0" anchor="ctr"/>
+          <a:lstStyle/>
+          <a:p>
+            <a:pPr algn="ctr" indent="0" marL="0">
+              <a:buNone/>
+            </a:pPr>
+            <a:r>
+              <a:rPr lang="en-US" sz="3000" i="1" dirty="0">
+                <a:solidFill>
+                  <a:srgbClr val="33394A"/>
+                </a:solidFill>
+                <a:latin typeface="Cambria" pitchFamily="34" charset="0"/>
+                <a:ea typeface="Cambria" pitchFamily="34" charset="-122"/>
+                <a:cs typeface="Cambria" pitchFamily="34" charset="-120"/>
+              </a:rPr>
+              <a:t>{{NOME DO PARTICIPANTE}}</a:t>
+            </a:r>
+            <a:endParaRPr lang="en-US" sz="3000" dirty="0"/>
+          </a:p>
+        </p:txBody>
+      </p:sp>
+      <p:sp>
+        <p:nvSpPr>
+          <p:cNvPr id="8" name="Text 6"/>
+          <p:cNvSpPr/>
+          <p:nvPr/>
+        </p:nvSpPr>
+        <p:spPr>
+          <a:xfrm>
+            <a:off x="1920240" y="3520440"/>
+            <a:ext cx="8348472" cy="1371600"/>
+          </a:xfrm>
+          <a:prstGeom prst="rect">
+            <a:avLst/>
+          </a:prstGeom>
+          <a:noFill/>
+          <a:ln/>
+        </p:spPr>
+        <p:txBody>
+          <a:bodyPr wrap="square" rtlCol="0" anchor="ctr"/>
+          <a:lstStyle/>
+          <a:p>
+            <a:pPr algn="ctr" indent="0" marL="0">
+              <a:lnSpc>
+                <a:spcPts val="2200"/>
+              </a:lnSpc>
+              <a:buNone/>
+            </a:pPr>
+            <a:r>
+              <a:rPr lang="en-US" sz="1400" dirty="0">
+                <a:solidFill>
+                  <a:srgbClr val="33394A"/>
                 </a:solidFill>
                 <a:latin typeface="Calibri" pitchFamily="34" charset="0"/>
                 <a:ea typeface="Calibri" pitchFamily="34" charset="-122"/>
                 <a:cs typeface="Calibri" pitchFamily="34" charset="-120"/>
               </a:rPr>
-              <a:t>Certificação de Campeão ABBA</a:t>
+              <a:t>graduou-se Campeão de IA da {{NOME_DA_EMPRESA}}: completou a trilha integral, construiu soluções próprias e assume o papel de multiplicador, com licença CrewAI de 12 meses concedida pela ABBA.</a:t>
             </a:r>
-            <a:endParaRPr lang="en-US" sz="3400" dirty="0"/>
-          </a:p>
-        </p:txBody>
-      </p:sp>
-      <p:sp>
-        <p:nvSpPr>
-          <p:cNvPr id="7" name="Text 4"/>
-          <p:cNvSpPr/>
-          <p:nvPr/>
-        </p:nvSpPr>
-        <p:spPr>
-          <a:xfrm>
-            <a:off x="548640" y="3383280"/>
-            <a:ext cx="11064240" cy="685800"/>
+            <a:endParaRPr lang="en-US" sz="1400" dirty="0"/>
+          </a:p>
+        </p:txBody>
+      </p:sp>
+      <p:sp>
+        <p:nvSpPr>
+          <p:cNvPr id="9" name="Text 7"/>
+          <p:cNvSpPr/>
+          <p:nvPr/>
+        </p:nvSpPr>
+        <p:spPr>
+          <a:xfrm>
+            <a:off x="822960" y="4983480"/>
+            <a:ext cx="10543032" cy="320040"/>
           </a:xfrm>
           <a:prstGeom prst="rect">
             <a:avLst/>
@@ -1547,37 +1629,60 @@
           <a:ln/>
         </p:spPr>
         <p:txBody>
-          <a:bodyPr wrap="square" lIns="0" tIns="0" rIns="0" bIns="0" rtlCol="0" anchor="ctr"/>
+          <a:bodyPr wrap="square" rtlCol="0" anchor="ctr"/>
           <a:lstStyle/>
           <a:p>
             <a:pPr algn="ctr" indent="0" marL="0">
               <a:buNone/>
             </a:pPr>
             <a:r>
-              <a:rPr lang="en-US" sz="3200" b="1" dirty="0">
+              <a:rPr lang="en-US" sz="1100" dirty="0">
                 <a:solidFill>
-                  <a:srgbClr val="C2A35B"/>
+                  <a:srgbClr val="6E6858"/>
                 </a:solidFill>
                 <a:latin typeface="Calibri" pitchFamily="34" charset="0"/>
                 <a:ea typeface="Calibri" pitchFamily="34" charset="-122"/>
                 <a:cs typeface="Calibri" pitchFamily="34" charset="-120"/>
               </a:rPr>
-              <a:t>{{NOME DO PARTICIPANTE}}</a:t>
+              <a:t>{{Cidade}}, {{data}}   ·   Verificação: ABBA-CERT-{{ANO}}-{{NUM}}</a:t>
             </a:r>
-            <a:endParaRPr lang="en-US" sz="3200" dirty="0"/>
-          </a:p>
-        </p:txBody>
-      </p:sp>
-      <p:sp>
-        <p:nvSpPr>
-          <p:cNvPr id="8" name="Text 5"/>
-          <p:cNvSpPr/>
-          <p:nvPr/>
-        </p:nvSpPr>
-        <p:spPr>
-          <a:xfrm>
-            <a:off x="1463040" y="4160520"/>
-            <a:ext cx="9235440" cy="868680"/>
+            <a:endParaRPr lang="en-US" sz="1100" dirty="0"/>
+          </a:p>
+        </p:txBody>
+      </p:sp>
+      <p:sp>
+        <p:nvSpPr>
+          <p:cNvPr id="10" name="Shape 8"/>
+          <p:cNvSpPr/>
+          <p:nvPr/>
+        </p:nvSpPr>
+        <p:spPr>
+          <a:xfrm>
+            <a:off x="2528316" y="5806440"/>
+            <a:ext cx="3108960" cy="0"/>
+          </a:xfrm>
+          <a:prstGeom prst="line">
+            <a:avLst/>
+          </a:prstGeom>
+          <a:noFill/>
+          <a:ln w="9525">
+            <a:solidFill>
+              <a:srgbClr val="6E6858"/>
+            </a:solidFill>
+            <a:prstDash val="solid"/>
+          </a:ln>
+        </p:spPr>
+      </p:sp>
+      <p:sp>
+        <p:nvSpPr>
+          <p:cNvPr id="11" name="Text 9"/>
+          <p:cNvSpPr/>
+          <p:nvPr/>
+        </p:nvSpPr>
+        <p:spPr>
+          <a:xfrm>
+            <a:off x="2528316" y="5897880"/>
+            <a:ext cx="3108960" cy="274320"/>
           </a:xfrm>
           <a:prstGeom prst="rect">
             <a:avLst/>
@@ -1586,140 +1691,16 @@
           <a:ln/>
         </p:spPr>
         <p:txBody>
-          <a:bodyPr wrap="square" lIns="0" tIns="0" rIns="0" bIns="0" rtlCol="0" anchor="ctr"/>
+          <a:bodyPr wrap="square" rtlCol="0" anchor="ctr"/>
           <a:lstStyle/>
           <a:p>
             <a:pPr algn="ctr" indent="0" marL="0">
               <a:buNone/>
             </a:pPr>
             <a:r>
-              <a:rPr lang="en-US" sz="1400" dirty="0">
+              <a:rPr lang="en-US" sz="1100" dirty="0">
                 <a:solidFill>
-                  <a:srgbClr val="E8E8E8"/>
-                </a:solidFill>
-                <a:latin typeface="Calibri" pitchFamily="34" charset="0"/>
-                <a:ea typeface="Calibri" pitchFamily="34" charset="-122"/>
-                <a:cs typeface="Calibri" pitchFamily="34" charset="-120"/>
-              </a:rPr>
-              <a:t>graduou-se Campeão de IA da {{NOME_DA_EMPRESA}}: completou a trilha integral, construiu soluções próprias e assume o papel de multiplicador — com licença CrewAI de 12 meses concedida pela ABBA.</a:t>
-            </a:r>
-            <a:endParaRPr lang="en-US" sz="1400" dirty="0"/>
-          </a:p>
-        </p:txBody>
-      </p:sp>
-      <p:sp>
-        <p:nvSpPr>
-          <p:cNvPr id="9" name="Text 6"/>
-          <p:cNvSpPr/>
-          <p:nvPr/>
-        </p:nvSpPr>
-        <p:spPr>
-          <a:xfrm>
-            <a:off x="1463040" y="5074920"/>
-            <a:ext cx="9235440" cy="365760"/>
-          </a:xfrm>
-          <a:prstGeom prst="rect">
-            <a:avLst/>
-          </a:prstGeom>
-          <a:noFill/>
-          <a:ln/>
-        </p:spPr>
-        <p:txBody>
-          <a:bodyPr wrap="square" lIns="0" tIns="0" rIns="0" bIns="0" rtlCol="0" anchor="ctr"/>
-          <a:lstStyle/>
-          <a:p>
-            <a:pPr algn="ctr" indent="0" marL="0">
-              <a:buNone/>
-            </a:pPr>
-            <a:r>
-              <a:rPr lang="en-US" sz="1200" i="1" dirty="0">
-                <a:solidFill>
-                  <a:srgbClr val="5A6472"/>
-                </a:solidFill>
-                <a:latin typeface="Calibri" pitchFamily="34" charset="0"/>
-                <a:ea typeface="Calibri" pitchFamily="34" charset="-122"/>
-                <a:cs typeface="Calibri" pitchFamily="34" charset="-120"/>
-              </a:rPr>
-              <a:t>{{Cidade}}, {{data}} · Verificação: ABBA-CERT-{{ANO}}-{{NUM}}</a:t>
-            </a:r>
-            <a:endParaRPr lang="en-US" sz="1200" dirty="0"/>
-          </a:p>
-        </p:txBody>
-      </p:sp>
-      <p:sp>
-        <p:nvSpPr>
-          <p:cNvPr id="10" name="Shape 7"/>
-          <p:cNvSpPr/>
-          <p:nvPr/>
-        </p:nvSpPr>
-        <p:spPr>
-          <a:xfrm>
-            <a:off x="3108960" y="5806440"/>
-            <a:ext cx="2377440" cy="0"/>
-          </a:xfrm>
-          <a:prstGeom prst="line">
-            <a:avLst/>
-          </a:prstGeom>
-          <a:noFill/>
-          <a:ln w="12700">
-            <a:solidFill>
-              <a:srgbClr val="E8E8E8"/>
-            </a:solidFill>
-            <a:prstDash val="solid"/>
-          </a:ln>
-        </p:spPr>
-      </p:sp>
-      <p:sp>
-        <p:nvSpPr>
-          <p:cNvPr id="11" name="Shape 8"/>
-          <p:cNvSpPr/>
-          <p:nvPr/>
-        </p:nvSpPr>
-        <p:spPr>
-          <a:xfrm>
-            <a:off x="6675120" y="5806440"/>
-            <a:ext cx="2377440" cy="0"/>
-          </a:xfrm>
-          <a:prstGeom prst="line">
-            <a:avLst/>
-          </a:prstGeom>
-          <a:noFill/>
-          <a:ln w="12700">
-            <a:solidFill>
-              <a:srgbClr val="E8E8E8"/>
-            </a:solidFill>
-            <a:prstDash val="solid"/>
-          </a:ln>
-        </p:spPr>
-      </p:sp>
-      <p:sp>
-        <p:nvSpPr>
-          <p:cNvPr id="12" name="Text 9"/>
-          <p:cNvSpPr/>
-          <p:nvPr/>
-        </p:nvSpPr>
-        <p:spPr>
-          <a:xfrm>
-            <a:off x="3108960" y="5870448"/>
-            <a:ext cx="2377440" cy="274320"/>
-          </a:xfrm>
-          <a:prstGeom prst="rect">
-            <a:avLst/>
-          </a:prstGeom>
-          <a:noFill/>
-          <a:ln/>
-        </p:spPr>
-        <p:txBody>
-          <a:bodyPr wrap="square" lIns="0" tIns="0" rIns="0" bIns="0" rtlCol="0" anchor="ctr"/>
-          <a:lstStyle/>
-          <a:p>
-            <a:pPr algn="ctr" indent="0" marL="0">
-              <a:buNone/>
-            </a:pPr>
-            <a:r>
-              <a:rPr lang="en-US" sz="1000" dirty="0">
-                <a:solidFill>
-                  <a:srgbClr val="5A6472"/>
+                  <a:srgbClr val="33394A"/>
                 </a:solidFill>
                 <a:latin typeface="Calibri" pitchFamily="34" charset="0"/>
                 <a:ea typeface="Calibri" pitchFamily="34" charset="-122"/>
@@ -1727,20 +1708,43 @@
               </a:rPr>
               <a:t>{{Sócio A}} · ABBA</a:t>
             </a:r>
-            <a:endParaRPr lang="en-US" sz="1000" dirty="0"/>
-          </a:p>
-        </p:txBody>
-      </p:sp>
-      <p:sp>
-        <p:nvSpPr>
-          <p:cNvPr id="13" name="Text 10"/>
-          <p:cNvSpPr/>
-          <p:nvPr/>
-        </p:nvSpPr>
-        <p:spPr>
-          <a:xfrm>
-            <a:off x="6675120" y="5870448"/>
-            <a:ext cx="2377440" cy="274320"/>
+            <a:endParaRPr lang="en-US" sz="1100" dirty="0"/>
+          </a:p>
+        </p:txBody>
+      </p:sp>
+      <p:sp>
+        <p:nvSpPr>
+          <p:cNvPr id="12" name="Shape 10"/>
+          <p:cNvSpPr/>
+          <p:nvPr/>
+        </p:nvSpPr>
+        <p:spPr>
+          <a:xfrm>
+            <a:off x="6551676" y="5806440"/>
+            <a:ext cx="3108960" cy="0"/>
+          </a:xfrm>
+          <a:prstGeom prst="line">
+            <a:avLst/>
+          </a:prstGeom>
+          <a:noFill/>
+          <a:ln w="9525">
+            <a:solidFill>
+              <a:srgbClr val="6E6858"/>
+            </a:solidFill>
+            <a:prstDash val="solid"/>
+          </a:ln>
+        </p:spPr>
+      </p:sp>
+      <p:sp>
+        <p:nvSpPr>
+          <p:cNvPr id="13" name="Text 11"/>
+          <p:cNvSpPr/>
+          <p:nvPr/>
+        </p:nvSpPr>
+        <p:spPr>
+          <a:xfrm>
+            <a:off x="6551676" y="5897880"/>
+            <a:ext cx="3108960" cy="274320"/>
           </a:xfrm>
           <a:prstGeom prst="rect">
             <a:avLst/>
@@ -1749,16 +1753,16 @@
           <a:ln/>
         </p:spPr>
         <p:txBody>
-          <a:bodyPr wrap="square" lIns="0" tIns="0" rIns="0" bIns="0" rtlCol="0" anchor="ctr"/>
+          <a:bodyPr wrap="square" rtlCol="0" anchor="ctr"/>
           <a:lstStyle/>
           <a:p>
             <a:pPr algn="ctr" indent="0" marL="0">
               <a:buNone/>
             </a:pPr>
             <a:r>
-              <a:rPr lang="en-US" sz="1000" dirty="0">
+              <a:rPr lang="en-US" sz="1100" dirty="0">
                 <a:solidFill>
-                  <a:srgbClr val="5A6472"/>
+                  <a:srgbClr val="33394A"/>
                 </a:solidFill>
                 <a:latin typeface="Calibri" pitchFamily="34" charset="0"/>
                 <a:ea typeface="Calibri" pitchFamily="34" charset="-122"/>
@@ -1766,7 +1770,7 @@
               </a:rPr>
               <a:t>{{Sócio B}} · ABBA</a:t>
             </a:r>
-            <a:endParaRPr lang="en-US" sz="1000" dirty="0"/>
+            <a:endParaRPr lang="en-US" sz="1100" dirty="0"/>
           </a:p>
         </p:txBody>
       </p:sp>

</xml_diff>